<commit_message>
Update the jury deck: business model slide and accurate future work
The deck in docs/ was the 15-slide version. This is the current 16-slide
deck: it adds the Business Model slide, and rewords Future Work to what
MVP 2 built and measured. The next paper keeps weak material in and swaps
mastered material for untested material (E9); it does not concentrate on
weak topics, so the slide no longer says it does. Written answers are
marked against the model answer, not a rubric, and low-confidence marks
are flagged for a teacher rather than routed to one.
</commit_message>
<xml_diff>
--- a/docs/Prepify-Jury-Presentation.pptx
+++ b/docs/Prepify-Jury-Presentation.pptx
@@ -22,6 +22,7 @@
     <p:sldId id="267" r:id="rId13"/>
     <p:sldId id="268" r:id="rId14"/>
     <p:sldId id="270" r:id="rId15"/>
+    <p:sldId id="271" r:id="rId22"/>
     <p:sldId id="269" r:id="rId16"/>
   </p:sldIdLst>
   <p:sldSz cx="12192000" cy="6858000"/>
@@ -766,15 +767,13 @@
           <a:lstStyle/>
           <a:p>
             <a:r>
-              <a:t>[1:00]  The repo is already named Generator and Grader — this is the next MVP. Walk the loop left to right: today we generate; next, students answer, we grade, and weak topics re-weight the solver. Objective marking is deterministic; written answers get a rubric, the cited passage, and a teacher for low-confidence marks — the same honesty as slide 12.</a:t>
-            </a:r>
-          </a:p>
-          <a:p>
-            <a:endParaRPr/>
-          </a:p>
-          <a:p>
-            <a:r>
-              <a:t>NEXT:  "Let me finish where I started."</a:t>
+              <a:t>[1:00]  The repo is already named Generator and Grader — this is the next MVP. Walk the loop left to right: today we generate; next, students answer, we grade, and their answers re-weight the solver. Objective marks come from the stored key, no model. Written answers are marked against the model answer and the cited passage; low-confidence marks are flagged for a teacher, and any mark can be contested — the same honesty as slide 12. The loop: mastered material makes way for material the student has not been tested on, and what they missed comes back as spaced re-tests. If asked whether it drills weak topics: no — a passage carries one question per paper, so it keeps weak material in rather than piling on; drilling is the review set’s job.</a:t>
+            </a:r>
+          </a:p>
+          <a:p/>
+          <a:p>
+            <a:r>
+              <a:t>NEXT:  "And here's how it pays for itself."</a:t>
             </a:r>
           </a:p>
         </p:txBody>
@@ -897,6 +896,93 @@
         <p14:creationId xmlns:p14="http://schemas.microsoft.com/office/powerpoint/2010/main" val="1024086991"/>
       </p:ext>
     </p:extLst>
+  </p:cSld>
+  <p:clrMapOvr>
+    <a:masterClrMapping/>
+  </p:clrMapOvr>
+</p:notes>
+</file>
+
+<file path=ppt/notesSlides/notesSlide16.xml><?xml version="1.0" encoding="utf-8"?>
+<p:notes xmlns:a="http://schemas.openxmlformats.org/drawingml/2006/main" xmlns:p="http://schemas.openxmlformats.org/presentationml/2006/main" xmlns:r="http://schemas.openxmlformats.org/officeDocument/2006/relationships">
+  <p:cSld>
+    <p:spTree>
+      <p:nvGrpSpPr>
+        <p:cNvPr id="1" name=""/>
+        <p:cNvGrpSpPr/>
+        <p:nvPr/>
+      </p:nvGrpSpPr>
+      <p:grpSpPr>
+        <a:xfrm>
+          <a:off x="0" y="0"/>
+          <a:ext cx="0" cy="0"/>
+          <a:chOff x="0" y="0"/>
+          <a:chExt cx="0" cy="0"/>
+        </a:xfrm>
+      </p:grpSpPr>
+      <p:sp>
+        <p:nvSpPr>
+          <p:cNvPr id="2" name="Slide Image Placeholder 1"/>
+          <p:cNvSpPr>
+            <a:spLocks noGrp="1" noRot="1" noChangeAspect="1"/>
+          </p:cNvSpPr>
+          <p:nvPr>
+            <p:ph type="sldImg"/>
+          </p:nvPr>
+        </p:nvSpPr>
+        <p:spPr/>
+      </p:sp>
+      <p:sp>
+        <p:nvSpPr>
+          <p:cNvPr id="3" name="Notes Placeholder 2"/>
+          <p:cNvSpPr>
+            <a:spLocks noGrp="1"/>
+          </p:cNvSpPr>
+          <p:nvPr>
+            <p:ph type="body" idx="1"/>
+          </p:nvPr>
+        </p:nvSpPr>
+        <p:spPr/>
+        <p:txBody>
+          <a:bodyPr/>
+          <a:lstStyle/>
+          <a:p>
+            <a:r>
+              <a:t>[1:00]  Standard subscription, seven-day trial, no card required — many students don't have a credit card, and reviews of competitors' trials warn about surprise auto-renewals. Student pricing sits below Quizlet and well below StudyFetch and Chegg, with a regional rupee price. Marginal cost stays low because the model does so little: about four calls per paper, and a cached re-run costs nothing. Instructors pay for what students cannot get elsewhere — a coverage report for every paper, and the grader as it ships.</a:t>
+            </a:r>
+          </a:p>
+          <a:p/>
+          <a:p>
+            <a:r>
+              <a:t>NEXT:  "Let me finish where I started."</a:t>
+            </a:r>
+          </a:p>
+        </p:txBody>
+      </p:sp>
+      <p:sp>
+        <p:nvSpPr>
+          <p:cNvPr id="4" name="Slide Number Placeholder 3"/>
+          <p:cNvSpPr>
+            <a:spLocks noGrp="1"/>
+          </p:cNvSpPr>
+          <p:nvPr>
+            <p:ph type="sldNum" sz="quarter" idx="10"/>
+          </p:nvPr>
+        </p:nvSpPr>
+        <p:spPr/>
+        <p:txBody>
+          <a:bodyPr/>
+          <a:lstStyle/>
+          <a:p>
+            <a:fld id="{F7021451-1387-4CA6-816F-3879F97B5CBC}" type="slidenum">
+              <a:rPr lang="en-US"/>
+              <a:t>13</a:t>
+            </a:fld>
+            <a:endParaRPr lang="en-US"/>
+          </a:p>
+        </p:txBody>
+      </p:sp>
+    </p:spTree>
   </p:cSld>
   <p:clrMapOvr>
     <a:masterClrMapping/>
@@ -7710,7 +7796,7 @@
                 </a:solidFill>
                 <a:latin typeface="Calibri"/>
               </a:rPr>
-              <a:t>weak topics feed the next paper</a:t>
+              <a:t>your answers shape the next paper</a:t>
             </a:r>
           </a:p>
         </p:txBody>
@@ -7868,7 +7954,7 @@
                 </a:solidFill>
                 <a:latin typeface="Calibri"/>
               </a:rPr>
-              <a:t>Written answers marked against a rubric and the question's own cited passage.</a:t>
+              <a:t>Written answers marked against the model answer and the question's own cited passage.</a:t>
             </a:r>
           </a:p>
         </p:txBody>
@@ -7947,7 +8033,7 @@
                 </a:solidFill>
                 <a:latin typeface="Calibri"/>
               </a:rPr>
-              <a:t>Low-confidence marks go to a teacher; feedback names the page to revise.</a:t>
+              <a:t>Low-confidence marks say “check with your teacher”; feedback names the page to revise.</a:t>
             </a:r>
           </a:p>
         </p:txBody>
@@ -8026,7 +8112,7 @@
                 </a:solidFill>
                 <a:latin typeface="Calibri"/>
               </a:rPr>
-              <a:t>Weak topics re-weight the solver, so the next paper targets them.</a:t>
+              <a:t>Mastered material makes way for untested material; misses return as spaced re-tests.</a:t>
             </a:r>
           </a:p>
         </p:txBody>
@@ -8606,6 +8692,2577 @@
 </file>
 
 <file path=ppt/slides/slide15.xml><?xml version="1.0" encoding="utf-8"?>
+<p:sld xmlns:a="http://schemas.openxmlformats.org/drawingml/2006/main" xmlns:r="http://schemas.openxmlformats.org/officeDocument/2006/relationships" xmlns:p="http://schemas.openxmlformats.org/presentationml/2006/main">
+  <p:cSld name="Slide 13">
+    <p:bg>
+      <p:bgPr>
+        <a:blipFill dpi="0" rotWithShape="1">
+          <a:blip r:embed="rId3">
+            <a:lum/>
+          </a:blip>
+          <a:srcRect/>
+          <a:stretch>
+            <a:fillRect/>
+          </a:stretch>
+        </a:blipFill>
+        <a:effectLst/>
+      </p:bgPr>
+    </p:bg>
+    <p:spTree>
+      <p:nvGrpSpPr>
+        <p:cNvPr id="1" name=""/>
+        <p:cNvGrpSpPr/>
+        <p:nvPr/>
+      </p:nvGrpSpPr>
+      <p:grpSpPr>
+        <a:xfrm>
+          <a:off x="0" y="0"/>
+          <a:ext cx="0" cy="0"/>
+          <a:chOff x="0" y="0"/>
+          <a:chExt cx="0" cy="0"/>
+        </a:xfrm>
+      </p:grpSpPr>
+      <p:sp>
+        <p:nvSpPr>
+          <p:cNvPr id="2" name="Shape 0"/>
+          <p:cNvSpPr/>
+          <p:nvPr/>
+        </p:nvSpPr>
+        <p:spPr>
+          <a:xfrm>
+            <a:off x="658368" y="548640"/>
+            <a:ext cx="173736" cy="173736"/>
+          </a:xfrm>
+          <a:prstGeom prst="rect">
+            <a:avLst/>
+          </a:prstGeom>
+          <a:solidFill>
+            <a:srgbClr val="E8A33D"/>
+          </a:solidFill>
+          <a:ln w="12700">
+            <a:solidFill>
+              <a:srgbClr val="E8A33D"/>
+            </a:solidFill>
+            <a:prstDash val="solid"/>
+          </a:ln>
+        </p:spPr>
+        <p:txBody>
+          <a:bodyPr/>
+          <a:lstStyle/>
+          <a:p>
+            <a:endParaRPr lang="en-US"/>
+          </a:p>
+        </p:txBody>
+      </p:sp>
+      <p:sp>
+        <p:nvSpPr>
+          <p:cNvPr id="3" name="Text 1"/>
+          <p:cNvSpPr txBox="1"/>
+          <p:nvPr/>
+        </p:nvSpPr>
+        <p:spPr>
+          <a:xfrm>
+            <a:off x="960120" y="475488"/>
+            <a:ext cx="8229600" cy="310896"/>
+          </a:xfrm>
+          <a:prstGeom prst="rect">
+            <a:avLst/>
+          </a:prstGeom>
+          <a:noFill/>
+          <a:ln/>
+        </p:spPr>
+        <p:txBody>
+          <a:bodyPr wrap="square" lIns="0" tIns="0" rIns="0" bIns="0" rtlCol="0" anchor="ctr"/>
+          <a:lstStyle/>
+          <a:p>
+            <a:pPr marL="0" indent="0">
+              <a:buNone/>
+            </a:pPr>
+            <a:r>
+              <a:rPr lang="en-US" sz="1200" b="1" kern="0" spc="300" dirty="0">
+                <a:solidFill>
+                  <a:srgbClr val="0F4C81"/>
+                </a:solidFill>
+                <a:latin typeface="Calibri" pitchFamily="34" charset="0"/>
+                <a:ea typeface="Calibri" pitchFamily="34" charset="-122"/>
+                <a:cs typeface="Calibri" pitchFamily="34" charset="-120"/>
+              </a:rPr>
+              <a:t>SUBSCRIPTION · 7-DAY TRIAL</a:t>
+            </a:r>
+            <a:endParaRPr lang="en-US" sz="1200" dirty="0"/>
+          </a:p>
+        </p:txBody>
+      </p:sp>
+      <p:sp>
+        <p:nvSpPr>
+          <p:cNvPr id="4" name="Text 2"/>
+          <p:cNvSpPr txBox="1"/>
+          <p:nvPr/>
+        </p:nvSpPr>
+        <p:spPr>
+          <a:xfrm>
+            <a:off x="658368" y="914400"/>
+            <a:ext cx="10881360" cy="868680"/>
+          </a:xfrm>
+          <a:prstGeom prst="rect">
+            <a:avLst/>
+          </a:prstGeom>
+          <a:noFill/>
+          <a:ln/>
+        </p:spPr>
+        <p:txBody>
+          <a:bodyPr wrap="square" lIns="0" tIns="0" rIns="0" bIns="0" rtlCol="0" anchor="ctr"/>
+          <a:lstStyle/>
+          <a:p>
+            <a:pPr marL="0" indent="0">
+              <a:buNone/>
+            </a:pPr>
+            <a:r>
+              <a:rPr lang="en-US" sz="3600" b="1" dirty="0">
+                <a:solidFill>
+                  <a:srgbClr val="0F1620"/>
+                </a:solidFill>
+                <a:latin typeface="Calibri" pitchFamily="34" charset="0"/>
+                <a:ea typeface="Calibri" pitchFamily="34" charset="-122"/>
+                <a:cs typeface="Calibri" pitchFamily="34" charset="-120"/>
+              </a:rPr>
+              <a:t>Business model</a:t>
+            </a:r>
+            <a:endParaRPr lang="en-US" sz="3600" dirty="0"/>
+          </a:p>
+        </p:txBody>
+      </p:sp>
+      <p:sp>
+        <p:nvSpPr>
+          <p:cNvPr id="27" name="Text 25"/>
+          <p:cNvSpPr txBox="1"/>
+          <p:nvPr/>
+        </p:nvSpPr>
+        <p:spPr>
+          <a:xfrm>
+            <a:off x="658368" y="6327648"/>
+            <a:ext cx="2743200" cy="256032"/>
+          </a:xfrm>
+          <a:prstGeom prst="rect">
+            <a:avLst/>
+          </a:prstGeom>
+          <a:noFill/>
+          <a:ln/>
+        </p:spPr>
+        <p:txBody>
+          <a:bodyPr wrap="square" lIns="0" tIns="0" rIns="0" bIns="0" rtlCol="0" anchor="ctr"/>
+          <a:lstStyle/>
+          <a:p>
+            <a:pPr marL="0" indent="0">
+              <a:buNone/>
+            </a:pPr>
+            <a:r>
+              <a:rPr lang="en-US" sz="950" kern="0" spc="140" dirty="0">
+                <a:solidFill>
+                  <a:srgbClr val="6B7A8C"/>
+                </a:solidFill>
+                <a:latin typeface="Calibri" pitchFamily="34" charset="0"/>
+                <a:ea typeface="Calibri" pitchFamily="34" charset="-122"/>
+                <a:cs typeface="Calibri" pitchFamily="34" charset="-120"/>
+              </a:rPr>
+              <a:t>Prepify</a:t>
+            </a:r>
+            <a:endParaRPr lang="en-US" sz="950" dirty="0"/>
+          </a:p>
+        </p:txBody>
+      </p:sp>
+      <p:sp>
+        <p:nvSpPr>
+          <p:cNvPr id="28" name="Text 26"/>
+          <p:cNvSpPr txBox="1"/>
+          <p:nvPr/>
+        </p:nvSpPr>
+        <p:spPr>
+          <a:xfrm>
+            <a:off x="10881360" y="6327648"/>
+            <a:ext cx="640080" cy="256032"/>
+          </a:xfrm>
+          <a:prstGeom prst="rect">
+            <a:avLst/>
+          </a:prstGeom>
+          <a:noFill/>
+          <a:ln/>
+        </p:spPr>
+        <p:txBody>
+          <a:bodyPr wrap="square" lIns="0" tIns="0" rIns="0" bIns="0" rtlCol="0" anchor="ctr"/>
+          <a:lstStyle/>
+          <a:p>
+            <a:pPr marL="0" indent="0" algn="r">
+              <a:buNone/>
+            </a:pPr>
+            <a:r>
+              <a:rPr lang="en-US" sz="950" b="1" dirty="0">
+                <a:solidFill>
+                  <a:srgbClr val="0F4C81"/>
+                </a:solidFill>
+                <a:latin typeface="Calibri" pitchFamily="34" charset="0"/>
+                <a:ea typeface="Calibri" pitchFamily="34" charset="-122"/>
+                <a:cs typeface="Calibri" pitchFamily="34" charset="-120"/>
+              </a:rPr>
+              <a:t>15</a:t>
+            </a:r>
+            <a:endParaRPr lang="en-US" sz="950" dirty="0"/>
+          </a:p>
+        </p:txBody>
+      </p:sp>
+      <p:sp>
+        <p:nvSpPr>
+          <p:cNvPr id="29" name="Rounded Rectangle 28"/>
+          <p:cNvSpPr/>
+          <p:nvPr/>
+        </p:nvSpPr>
+        <p:spPr>
+          <a:xfrm>
+            <a:off x="658368" y="1755648"/>
+            <a:ext cx="6903720" cy="530352"/>
+          </a:xfrm>
+          <a:prstGeom prst="roundRect">
+            <a:avLst>
+              <a:gd name="adj" fmla="val 12000"/>
+            </a:avLst>
+          </a:prstGeom>
+          <a:solidFill>
+            <a:srgbClr val="0F4C81"/>
+          </a:solidFill>
+          <a:ln>
+            <a:noFill/>
+          </a:ln>
+          <a:effectLst>
+            <a:outerShdw blurRad="177800" dist="38100" dir="5400000" algn="bl" rotWithShape="0">
+              <a:srgbClr val="0B2238">
+                <a:alpha val="13000"/>
+              </a:srgbClr>
+            </a:outerShdw>
+          </a:effectLst>
+        </p:spPr>
+        <p:style>
+          <a:lnRef idx="1">
+            <a:schemeClr val="accent1"/>
+          </a:lnRef>
+          <a:fillRef idx="3">
+            <a:schemeClr val="accent1"/>
+          </a:fillRef>
+          <a:effectRef idx="2">
+            <a:schemeClr val="accent1"/>
+          </a:effectRef>
+          <a:fontRef idx="minor">
+            <a:schemeClr val="lt1"/>
+          </a:fontRef>
+        </p:style>
+        <p:txBody>
+          <a:bodyPr rtlCol="0" anchor="ctr"/>
+          <a:lstStyle/>
+          <a:p/>
+        </p:txBody>
+      </p:sp>
+      <p:sp>
+        <p:nvSpPr>
+          <p:cNvPr id="30" name="TextBox 29"/>
+          <p:cNvSpPr txBox="1"/>
+          <p:nvPr/>
+        </p:nvSpPr>
+        <p:spPr>
+          <a:xfrm>
+            <a:off x="896112" y="1755648"/>
+            <a:ext cx="2011680" cy="530352"/>
+          </a:xfrm>
+          <a:prstGeom prst="rect">
+            <a:avLst/>
+          </a:prstGeom>
+          <a:noFill/>
+        </p:spPr>
+        <p:txBody>
+          <a:bodyPr wrap="square" lIns="0" rIns="0" tIns="0" bIns="0" anchor="ctr">
+            <a:spAutoFit/>
+          </a:bodyPr>
+          <a:lstStyle/>
+          <a:p>
+            <a:pPr algn="l"/>
+            <a:r>
+              <a:rPr sz="1200" b="1" i="0" spc="200">
+                <a:solidFill>
+                  <a:srgbClr val="4FD1C5"/>
+                </a:solidFill>
+                <a:latin typeface="Calibri"/>
+              </a:rPr>
+              <a:t>7-DAY FREE TRIAL</a:t>
+            </a:r>
+          </a:p>
+        </p:txBody>
+      </p:sp>
+      <p:sp>
+        <p:nvSpPr>
+          <p:cNvPr id="31" name="TextBox 30"/>
+          <p:cNvSpPr txBox="1"/>
+          <p:nvPr/>
+        </p:nvSpPr>
+        <p:spPr>
+          <a:xfrm>
+            <a:off x="2788920" y="1755648"/>
+            <a:ext cx="4617720" cy="530352"/>
+          </a:xfrm>
+          <a:prstGeom prst="rect">
+            <a:avLst/>
+          </a:prstGeom>
+          <a:noFill/>
+        </p:spPr>
+        <p:txBody>
+          <a:bodyPr wrap="square" lIns="0" rIns="0" tIns="0" bIns="0" anchor="ctr">
+            <a:spAutoFit/>
+          </a:bodyPr>
+          <a:lstStyle/>
+          <a:p>
+            <a:pPr algn="l"/>
+            <a:r>
+              <a:rPr sz="1250" b="0" i="0">
+                <a:solidFill>
+                  <a:srgbClr val="CFE2F3"/>
+                </a:solidFill>
+                <a:latin typeface="Calibri"/>
+              </a:rPr>
+              <a:t>Full Student access  ·  no card required  ·  cancel any time</a:t>
+            </a:r>
+          </a:p>
+        </p:txBody>
+      </p:sp>
+      <p:sp>
+        <p:nvSpPr>
+          <p:cNvPr id="32" name="Rounded Rectangle 31"/>
+          <p:cNvSpPr/>
+          <p:nvPr/>
+        </p:nvSpPr>
+        <p:spPr>
+          <a:xfrm>
+            <a:off x="658368" y="2542032"/>
+            <a:ext cx="2197303" cy="2670048"/>
+          </a:xfrm>
+          <a:prstGeom prst="roundRect">
+            <a:avLst>
+              <a:gd name="adj" fmla="val 6000"/>
+            </a:avLst>
+          </a:prstGeom>
+          <a:solidFill>
+            <a:srgbClr val="FFFFFF"/>
+          </a:solidFill>
+          <a:ln w="12700">
+            <a:solidFill>
+              <a:srgbClr val="D4E2EE"/>
+            </a:solidFill>
+          </a:ln>
+          <a:effectLst>
+            <a:outerShdw blurRad="177800" dist="38100" dir="5400000" algn="bl" rotWithShape="0">
+              <a:srgbClr val="0B2238">
+                <a:alpha val="13000"/>
+              </a:srgbClr>
+            </a:outerShdw>
+          </a:effectLst>
+        </p:spPr>
+        <p:style>
+          <a:lnRef idx="1">
+            <a:schemeClr val="accent1"/>
+          </a:lnRef>
+          <a:fillRef idx="3">
+            <a:schemeClr val="accent1"/>
+          </a:fillRef>
+          <a:effectRef idx="2">
+            <a:schemeClr val="accent1"/>
+          </a:effectRef>
+          <a:fontRef idx="minor">
+            <a:schemeClr val="lt1"/>
+          </a:fontRef>
+        </p:style>
+        <p:txBody>
+          <a:bodyPr rtlCol="0" anchor="ctr"/>
+          <a:lstStyle/>
+          <a:p/>
+        </p:txBody>
+      </p:sp>
+      <p:sp>
+        <p:nvSpPr>
+          <p:cNvPr id="33" name="TextBox 32"/>
+          <p:cNvSpPr txBox="1"/>
+          <p:nvPr/>
+        </p:nvSpPr>
+        <p:spPr>
+          <a:xfrm>
+            <a:off x="859536" y="2761487"/>
+            <a:ext cx="1794967" cy="219456"/>
+          </a:xfrm>
+          <a:prstGeom prst="rect">
+            <a:avLst/>
+          </a:prstGeom>
+          <a:noFill/>
+        </p:spPr>
+        <p:txBody>
+          <a:bodyPr wrap="square" lIns="0" rIns="0" tIns="0" bIns="0" anchor="t">
+            <a:spAutoFit/>
+          </a:bodyPr>
+          <a:lstStyle/>
+          <a:p>
+            <a:pPr algn="l"/>
+            <a:r>
+              <a:rPr sz="1000" b="1" i="0" spc="150">
+                <a:solidFill>
+                  <a:srgbClr val="0F4C81"/>
+                </a:solidFill>
+                <a:latin typeface="Calibri"/>
+              </a:rPr>
+              <a:t>STUDENT · MONTHLY</a:t>
+            </a:r>
+          </a:p>
+        </p:txBody>
+      </p:sp>
+      <p:sp>
+        <p:nvSpPr>
+          <p:cNvPr id="34" name="TextBox 33"/>
+          <p:cNvSpPr txBox="1"/>
+          <p:nvPr/>
+        </p:nvSpPr>
+        <p:spPr>
+          <a:xfrm>
+            <a:off x="859536" y="2999232"/>
+            <a:ext cx="1794967" cy="548640"/>
+          </a:xfrm>
+          <a:prstGeom prst="rect">
+            <a:avLst/>
+          </a:prstGeom>
+          <a:noFill/>
+        </p:spPr>
+        <p:txBody>
+          <a:bodyPr wrap="square" lIns="0" rIns="0" tIns="0" bIns="0" anchor="t">
+            <a:spAutoFit/>
+          </a:bodyPr>
+          <a:lstStyle/>
+          <a:p>
+            <a:pPr algn="l"/>
+            <a:r>
+              <a:rPr sz="3000" b="1" i="0">
+                <a:solidFill>
+                  <a:srgbClr val="0F4C81"/>
+                </a:solidFill>
+                <a:latin typeface="Calibri"/>
+              </a:rPr>
+              <a:t>$5.99</a:t>
+            </a:r>
+            <a:r>
+              <a:rPr sz="1200" b="0" i="0">
+                <a:solidFill>
+                  <a:srgbClr val="6B7A8C"/>
+                </a:solidFill>
+                <a:latin typeface="Calibri"/>
+              </a:rPr>
+              <a:t> / month</a:t>
+            </a:r>
+          </a:p>
+        </p:txBody>
+      </p:sp>
+      <p:sp>
+        <p:nvSpPr>
+          <p:cNvPr id="35" name="TextBox 34"/>
+          <p:cNvSpPr txBox="1"/>
+          <p:nvPr/>
+        </p:nvSpPr>
+        <p:spPr>
+          <a:xfrm>
+            <a:off x="859536" y="3547872"/>
+            <a:ext cx="1794967" cy="237744"/>
+          </a:xfrm>
+          <a:prstGeom prst="rect">
+            <a:avLst/>
+          </a:prstGeom>
+          <a:noFill/>
+        </p:spPr>
+        <p:txBody>
+          <a:bodyPr wrap="square" lIns="0" rIns="0" tIns="0" bIns="0" anchor="t">
+            <a:spAutoFit/>
+          </a:bodyPr>
+          <a:lstStyle/>
+          <a:p>
+            <a:pPr algn="l"/>
+            <a:r>
+              <a:rPr sz="1050" b="0" i="1">
+                <a:solidFill>
+                  <a:srgbClr val="6B7A8C"/>
+                </a:solidFill>
+                <a:latin typeface="Calibri"/>
+              </a:rPr>
+              <a:t>PKR 999/month in Pakistan</a:t>
+            </a:r>
+          </a:p>
+        </p:txBody>
+      </p:sp>
+      <p:sp>
+        <p:nvSpPr>
+          <p:cNvPr id="36" name="Oval 35"/>
+          <p:cNvSpPr/>
+          <p:nvPr/>
+        </p:nvSpPr>
+        <p:spPr>
+          <a:xfrm>
+            <a:off x="859536" y="4023360"/>
+            <a:ext cx="91440" cy="91440"/>
+          </a:xfrm>
+          <a:prstGeom prst="ellipse">
+            <a:avLst/>
+          </a:prstGeom>
+          <a:solidFill>
+            <a:srgbClr val="0F4C81"/>
+          </a:solidFill>
+          <a:ln>
+            <a:noFill/>
+          </a:ln>
+        </p:spPr>
+        <p:style>
+          <a:lnRef idx="1">
+            <a:schemeClr val="accent1"/>
+          </a:lnRef>
+          <a:fillRef idx="3">
+            <a:schemeClr val="accent1"/>
+          </a:fillRef>
+          <a:effectRef idx="2">
+            <a:schemeClr val="accent1"/>
+          </a:effectRef>
+          <a:fontRef idx="minor">
+            <a:schemeClr val="lt1"/>
+          </a:fontRef>
+        </p:style>
+        <p:txBody>
+          <a:bodyPr rtlCol="0" anchor="ctr"/>
+          <a:lstStyle/>
+          <a:p>
+            <a:pPr algn="ctr"/>
+          </a:p>
+        </p:txBody>
+      </p:sp>
+      <p:sp>
+        <p:nvSpPr>
+          <p:cNvPr id="37" name="TextBox 36"/>
+          <p:cNvSpPr txBox="1"/>
+          <p:nvPr/>
+        </p:nvSpPr>
+        <p:spPr>
+          <a:xfrm>
+            <a:off x="1042415" y="3959352"/>
+            <a:ext cx="1612087" cy="274320"/>
+          </a:xfrm>
+          <a:prstGeom prst="rect">
+            <a:avLst/>
+          </a:prstGeom>
+          <a:noFill/>
+        </p:spPr>
+        <p:txBody>
+          <a:bodyPr wrap="square" lIns="0" rIns="0" tIns="0" bIns="0" anchor="t">
+            <a:spAutoFit/>
+          </a:bodyPr>
+          <a:lstStyle/>
+          <a:p>
+            <a:pPr algn="l"/>
+            <a:r>
+              <a:rPr sz="1100" b="0" i="0">
+                <a:solidFill>
+                  <a:srgbClr val="0F1620"/>
+                </a:solidFill>
+                <a:latin typeface="Calibri"/>
+              </a:rPr>
+              <a:t>Upload your own decks</a:t>
+            </a:r>
+          </a:p>
+        </p:txBody>
+      </p:sp>
+      <p:sp>
+        <p:nvSpPr>
+          <p:cNvPr id="38" name="Oval 37"/>
+          <p:cNvSpPr/>
+          <p:nvPr/>
+        </p:nvSpPr>
+        <p:spPr>
+          <a:xfrm>
+            <a:off x="859536" y="4389120"/>
+            <a:ext cx="91440" cy="91440"/>
+          </a:xfrm>
+          <a:prstGeom prst="ellipse">
+            <a:avLst/>
+          </a:prstGeom>
+          <a:solidFill>
+            <a:srgbClr val="0F4C81"/>
+          </a:solidFill>
+          <a:ln>
+            <a:noFill/>
+          </a:ln>
+        </p:spPr>
+        <p:style>
+          <a:lnRef idx="1">
+            <a:schemeClr val="accent1"/>
+          </a:lnRef>
+          <a:fillRef idx="3">
+            <a:schemeClr val="accent1"/>
+          </a:fillRef>
+          <a:effectRef idx="2">
+            <a:schemeClr val="accent1"/>
+          </a:effectRef>
+          <a:fontRef idx="minor">
+            <a:schemeClr val="lt1"/>
+          </a:fontRef>
+        </p:style>
+        <p:txBody>
+          <a:bodyPr rtlCol="0" anchor="ctr"/>
+          <a:lstStyle/>
+          <a:p>
+            <a:pPr algn="ctr"/>
+          </a:p>
+        </p:txBody>
+      </p:sp>
+      <p:sp>
+        <p:nvSpPr>
+          <p:cNvPr id="39" name="TextBox 38"/>
+          <p:cNvSpPr txBox="1"/>
+          <p:nvPr/>
+        </p:nvSpPr>
+        <p:spPr>
+          <a:xfrm>
+            <a:off x="1042415" y="4325112"/>
+            <a:ext cx="1612087" cy="274320"/>
+          </a:xfrm>
+          <a:prstGeom prst="rect">
+            <a:avLst/>
+          </a:prstGeom>
+          <a:noFill/>
+        </p:spPr>
+        <p:txBody>
+          <a:bodyPr wrap="square" lIns="0" rIns="0" tIns="0" bIns="0" anchor="t">
+            <a:spAutoFit/>
+          </a:bodyPr>
+          <a:lstStyle/>
+          <a:p>
+            <a:pPr algn="l"/>
+            <a:r>
+              <a:rPr sz="1100" b="0" i="0">
+                <a:solidFill>
+                  <a:srgbClr val="0F1620"/>
+                </a:solidFill>
+                <a:latin typeface="Calibri"/>
+              </a:rPr>
+              <a:t>Papers with page citations</a:t>
+            </a:r>
+          </a:p>
+        </p:txBody>
+      </p:sp>
+      <p:sp>
+        <p:nvSpPr>
+          <p:cNvPr id="40" name="Oval 39"/>
+          <p:cNvSpPr/>
+          <p:nvPr/>
+        </p:nvSpPr>
+        <p:spPr>
+          <a:xfrm>
+            <a:off x="859536" y="4754880"/>
+            <a:ext cx="91440" cy="91440"/>
+          </a:xfrm>
+          <a:prstGeom prst="ellipse">
+            <a:avLst/>
+          </a:prstGeom>
+          <a:solidFill>
+            <a:srgbClr val="0F4C81"/>
+          </a:solidFill>
+          <a:ln>
+            <a:noFill/>
+          </a:ln>
+        </p:spPr>
+        <p:style>
+          <a:lnRef idx="1">
+            <a:schemeClr val="accent1"/>
+          </a:lnRef>
+          <a:fillRef idx="3">
+            <a:schemeClr val="accent1"/>
+          </a:fillRef>
+          <a:effectRef idx="2">
+            <a:schemeClr val="accent1"/>
+          </a:effectRef>
+          <a:fontRef idx="minor">
+            <a:schemeClr val="lt1"/>
+          </a:fontRef>
+        </p:style>
+        <p:txBody>
+          <a:bodyPr rtlCol="0" anchor="ctr"/>
+          <a:lstStyle/>
+          <a:p>
+            <a:pPr algn="ctr"/>
+          </a:p>
+        </p:txBody>
+      </p:sp>
+      <p:sp>
+        <p:nvSpPr>
+          <p:cNvPr id="41" name="TextBox 40"/>
+          <p:cNvSpPr txBox="1"/>
+          <p:nvPr/>
+        </p:nvSpPr>
+        <p:spPr>
+          <a:xfrm>
+            <a:off x="1042415" y="4690872"/>
+            <a:ext cx="1612087" cy="274320"/>
+          </a:xfrm>
+          <a:prstGeom prst="rect">
+            <a:avLst/>
+          </a:prstGeom>
+          <a:noFill/>
+        </p:spPr>
+        <p:txBody>
+          <a:bodyPr wrap="square" lIns="0" rIns="0" tIns="0" bIns="0" anchor="t">
+            <a:spAutoFit/>
+          </a:bodyPr>
+          <a:lstStyle/>
+          <a:p>
+            <a:pPr algn="l"/>
+            <a:r>
+              <a:rPr sz="1100" b="0" i="0">
+                <a:solidFill>
+                  <a:srgbClr val="0F1620"/>
+                </a:solidFill>
+                <a:latin typeface="Calibri"/>
+              </a:rPr>
+              <a:t>Chat over your material</a:t>
+            </a:r>
+          </a:p>
+        </p:txBody>
+      </p:sp>
+      <p:sp>
+        <p:nvSpPr>
+          <p:cNvPr id="42" name="Rounded Rectangle 41"/>
+          <p:cNvSpPr/>
+          <p:nvPr/>
+        </p:nvSpPr>
+        <p:spPr>
+          <a:xfrm>
+            <a:off x="3011119" y="2542032"/>
+            <a:ext cx="2197303" cy="2670048"/>
+          </a:xfrm>
+          <a:prstGeom prst="roundRect">
+            <a:avLst>
+              <a:gd name="adj" fmla="val 6000"/>
+            </a:avLst>
+          </a:prstGeom>
+          <a:solidFill>
+            <a:srgbClr val="0F4C81"/>
+          </a:solidFill>
+          <a:ln>
+            <a:noFill/>
+          </a:ln>
+          <a:effectLst>
+            <a:outerShdw blurRad="177800" dist="38100" dir="5400000" algn="bl" rotWithShape="0">
+              <a:srgbClr val="0B2238">
+                <a:alpha val="13000"/>
+              </a:srgbClr>
+            </a:outerShdw>
+          </a:effectLst>
+        </p:spPr>
+        <p:style>
+          <a:lnRef idx="1">
+            <a:schemeClr val="accent1"/>
+          </a:lnRef>
+          <a:fillRef idx="3">
+            <a:schemeClr val="accent1"/>
+          </a:fillRef>
+          <a:effectRef idx="2">
+            <a:schemeClr val="accent1"/>
+          </a:effectRef>
+          <a:fontRef idx="minor">
+            <a:schemeClr val="lt1"/>
+          </a:fontRef>
+        </p:style>
+        <p:txBody>
+          <a:bodyPr rtlCol="0" anchor="ctr"/>
+          <a:lstStyle/>
+          <a:p/>
+        </p:txBody>
+      </p:sp>
+      <p:sp>
+        <p:nvSpPr>
+          <p:cNvPr id="43" name="TextBox 42"/>
+          <p:cNvSpPr txBox="1"/>
+          <p:nvPr/>
+        </p:nvSpPr>
+        <p:spPr>
+          <a:xfrm>
+            <a:off x="3212287" y="2761487"/>
+            <a:ext cx="1794967" cy="219456"/>
+          </a:xfrm>
+          <a:prstGeom prst="rect">
+            <a:avLst/>
+          </a:prstGeom>
+          <a:noFill/>
+        </p:spPr>
+        <p:txBody>
+          <a:bodyPr wrap="square" lIns="0" rIns="0" tIns="0" bIns="0" anchor="t">
+            <a:spAutoFit/>
+          </a:bodyPr>
+          <a:lstStyle/>
+          <a:p>
+            <a:pPr algn="l"/>
+            <a:r>
+              <a:rPr sz="1000" b="1" i="0" spc="150">
+                <a:solidFill>
+                  <a:srgbClr val="4FD1C5"/>
+                </a:solidFill>
+                <a:latin typeface="Calibri"/>
+              </a:rPr>
+              <a:t>STUDENT · ANNUAL</a:t>
+            </a:r>
+          </a:p>
+        </p:txBody>
+      </p:sp>
+      <p:sp>
+        <p:nvSpPr>
+          <p:cNvPr id="44" name="TextBox 43"/>
+          <p:cNvSpPr txBox="1"/>
+          <p:nvPr/>
+        </p:nvSpPr>
+        <p:spPr>
+          <a:xfrm>
+            <a:off x="3212287" y="2999232"/>
+            <a:ext cx="1794967" cy="548640"/>
+          </a:xfrm>
+          <a:prstGeom prst="rect">
+            <a:avLst/>
+          </a:prstGeom>
+          <a:noFill/>
+        </p:spPr>
+        <p:txBody>
+          <a:bodyPr wrap="square" lIns="0" rIns="0" tIns="0" bIns="0" anchor="t">
+            <a:spAutoFit/>
+          </a:bodyPr>
+          <a:lstStyle/>
+          <a:p>
+            <a:pPr algn="l"/>
+            <a:r>
+              <a:rPr sz="3000" b="1" i="0">
+                <a:solidFill>
+                  <a:srgbClr val="FFFFFF"/>
+                </a:solidFill>
+                <a:latin typeface="Calibri"/>
+              </a:rPr>
+              <a:t>$39.99</a:t>
+            </a:r>
+            <a:r>
+              <a:rPr sz="1200" b="0" i="0">
+                <a:solidFill>
+                  <a:srgbClr val="9EC3E3"/>
+                </a:solidFill>
+                <a:latin typeface="Calibri"/>
+              </a:rPr>
+              <a:t> / year</a:t>
+            </a:r>
+          </a:p>
+        </p:txBody>
+      </p:sp>
+      <p:sp>
+        <p:nvSpPr>
+          <p:cNvPr id="45" name="TextBox 44"/>
+          <p:cNvSpPr txBox="1"/>
+          <p:nvPr/>
+        </p:nvSpPr>
+        <p:spPr>
+          <a:xfrm>
+            <a:off x="3212287" y="3547872"/>
+            <a:ext cx="1794967" cy="237744"/>
+          </a:xfrm>
+          <a:prstGeom prst="rect">
+            <a:avLst/>
+          </a:prstGeom>
+          <a:noFill/>
+        </p:spPr>
+        <p:txBody>
+          <a:bodyPr wrap="square" lIns="0" rIns="0" tIns="0" bIns="0" anchor="t">
+            <a:spAutoFit/>
+          </a:bodyPr>
+          <a:lstStyle/>
+          <a:p>
+            <a:pPr algn="l"/>
+            <a:r>
+              <a:rPr sz="1050" b="0" i="1">
+                <a:solidFill>
+                  <a:srgbClr val="9EC3E3"/>
+                </a:solidFill>
+                <a:latin typeface="Calibri"/>
+              </a:rPr>
+              <a:t>PKR 6,999/year in Pakistan</a:t>
+            </a:r>
+          </a:p>
+        </p:txBody>
+      </p:sp>
+      <p:sp>
+        <p:nvSpPr>
+          <p:cNvPr id="46" name="Oval 45"/>
+          <p:cNvSpPr/>
+          <p:nvPr/>
+        </p:nvSpPr>
+        <p:spPr>
+          <a:xfrm>
+            <a:off x="3212287" y="4023360"/>
+            <a:ext cx="91440" cy="91440"/>
+          </a:xfrm>
+          <a:prstGeom prst="ellipse">
+            <a:avLst/>
+          </a:prstGeom>
+          <a:solidFill>
+            <a:srgbClr val="4FD1C5"/>
+          </a:solidFill>
+          <a:ln>
+            <a:noFill/>
+          </a:ln>
+        </p:spPr>
+        <p:style>
+          <a:lnRef idx="1">
+            <a:schemeClr val="accent1"/>
+          </a:lnRef>
+          <a:fillRef idx="3">
+            <a:schemeClr val="accent1"/>
+          </a:fillRef>
+          <a:effectRef idx="2">
+            <a:schemeClr val="accent1"/>
+          </a:effectRef>
+          <a:fontRef idx="minor">
+            <a:schemeClr val="lt1"/>
+          </a:fontRef>
+        </p:style>
+        <p:txBody>
+          <a:bodyPr rtlCol="0" anchor="ctr"/>
+          <a:lstStyle/>
+          <a:p>
+            <a:pPr algn="ctr"/>
+          </a:p>
+        </p:txBody>
+      </p:sp>
+      <p:sp>
+        <p:nvSpPr>
+          <p:cNvPr id="47" name="TextBox 46"/>
+          <p:cNvSpPr txBox="1"/>
+          <p:nvPr/>
+        </p:nvSpPr>
+        <p:spPr>
+          <a:xfrm>
+            <a:off x="3395167" y="3959352"/>
+            <a:ext cx="1612087" cy="274320"/>
+          </a:xfrm>
+          <a:prstGeom prst="rect">
+            <a:avLst/>
+          </a:prstGeom>
+          <a:noFill/>
+        </p:spPr>
+        <p:txBody>
+          <a:bodyPr wrap="square" lIns="0" rIns="0" tIns="0" bIns="0" anchor="t">
+            <a:spAutoFit/>
+          </a:bodyPr>
+          <a:lstStyle/>
+          <a:p>
+            <a:pPr algn="l"/>
+            <a:r>
+              <a:rPr sz="1100" b="0" i="0">
+                <a:solidFill>
+                  <a:srgbClr val="CFE2F3"/>
+                </a:solidFill>
+                <a:latin typeface="Calibri"/>
+              </a:rPr>
+              <a:t>Everything in Monthly</a:t>
+            </a:r>
+          </a:p>
+        </p:txBody>
+      </p:sp>
+      <p:sp>
+        <p:nvSpPr>
+          <p:cNvPr id="48" name="Oval 47"/>
+          <p:cNvSpPr/>
+          <p:nvPr/>
+        </p:nvSpPr>
+        <p:spPr>
+          <a:xfrm>
+            <a:off x="3212287" y="4389120"/>
+            <a:ext cx="91440" cy="91440"/>
+          </a:xfrm>
+          <a:prstGeom prst="ellipse">
+            <a:avLst/>
+          </a:prstGeom>
+          <a:solidFill>
+            <a:srgbClr val="4FD1C5"/>
+          </a:solidFill>
+          <a:ln>
+            <a:noFill/>
+          </a:ln>
+        </p:spPr>
+        <p:style>
+          <a:lnRef idx="1">
+            <a:schemeClr val="accent1"/>
+          </a:lnRef>
+          <a:fillRef idx="3">
+            <a:schemeClr val="accent1"/>
+          </a:fillRef>
+          <a:effectRef idx="2">
+            <a:schemeClr val="accent1"/>
+          </a:effectRef>
+          <a:fontRef idx="minor">
+            <a:schemeClr val="lt1"/>
+          </a:fontRef>
+        </p:style>
+        <p:txBody>
+          <a:bodyPr rtlCol="0" anchor="ctr"/>
+          <a:lstStyle/>
+          <a:p>
+            <a:pPr algn="ctr"/>
+          </a:p>
+        </p:txBody>
+      </p:sp>
+      <p:sp>
+        <p:nvSpPr>
+          <p:cNvPr id="49" name="TextBox 48"/>
+          <p:cNvSpPr txBox="1"/>
+          <p:nvPr/>
+        </p:nvSpPr>
+        <p:spPr>
+          <a:xfrm>
+            <a:off x="3395167" y="4325112"/>
+            <a:ext cx="1612087" cy="274320"/>
+          </a:xfrm>
+          <a:prstGeom prst="rect">
+            <a:avLst/>
+          </a:prstGeom>
+          <a:noFill/>
+        </p:spPr>
+        <p:txBody>
+          <a:bodyPr wrap="square" lIns="0" rIns="0" tIns="0" bIns="0" anchor="t">
+            <a:spAutoFit/>
+          </a:bodyPr>
+          <a:lstStyle/>
+          <a:p>
+            <a:pPr algn="l"/>
+            <a:r>
+              <a:rPr sz="1100" b="0" i="0">
+                <a:solidFill>
+                  <a:srgbClr val="CFE2F3"/>
+                </a:solidFill>
+                <a:latin typeface="Calibri"/>
+              </a:rPr>
+              <a:t>$3.33 a month, save 44%</a:t>
+            </a:r>
+          </a:p>
+        </p:txBody>
+      </p:sp>
+      <p:sp>
+        <p:nvSpPr>
+          <p:cNvPr id="50" name="Oval 49"/>
+          <p:cNvSpPr/>
+          <p:nvPr/>
+        </p:nvSpPr>
+        <p:spPr>
+          <a:xfrm>
+            <a:off x="3212287" y="4754880"/>
+            <a:ext cx="91440" cy="91440"/>
+          </a:xfrm>
+          <a:prstGeom prst="ellipse">
+            <a:avLst/>
+          </a:prstGeom>
+          <a:solidFill>
+            <a:srgbClr val="4FD1C5"/>
+          </a:solidFill>
+          <a:ln>
+            <a:noFill/>
+          </a:ln>
+        </p:spPr>
+        <p:style>
+          <a:lnRef idx="1">
+            <a:schemeClr val="accent1"/>
+          </a:lnRef>
+          <a:fillRef idx="3">
+            <a:schemeClr val="accent1"/>
+          </a:fillRef>
+          <a:effectRef idx="2">
+            <a:schemeClr val="accent1"/>
+          </a:effectRef>
+          <a:fontRef idx="minor">
+            <a:schemeClr val="lt1"/>
+          </a:fontRef>
+        </p:style>
+        <p:txBody>
+          <a:bodyPr rtlCol="0" anchor="ctr"/>
+          <a:lstStyle/>
+          <a:p>
+            <a:pPr algn="ctr"/>
+          </a:p>
+        </p:txBody>
+      </p:sp>
+      <p:sp>
+        <p:nvSpPr>
+          <p:cNvPr id="51" name="TextBox 50"/>
+          <p:cNvSpPr txBox="1"/>
+          <p:nvPr/>
+        </p:nvSpPr>
+        <p:spPr>
+          <a:xfrm>
+            <a:off x="3395167" y="4690872"/>
+            <a:ext cx="1612087" cy="274320"/>
+          </a:xfrm>
+          <a:prstGeom prst="rect">
+            <a:avLst/>
+          </a:prstGeom>
+          <a:noFill/>
+        </p:spPr>
+        <p:txBody>
+          <a:bodyPr wrap="square" lIns="0" rIns="0" tIns="0" bIns="0" anchor="t">
+            <a:spAutoFit/>
+          </a:bodyPr>
+          <a:lstStyle/>
+          <a:p>
+            <a:pPr algn="l"/>
+            <a:r>
+              <a:rPr sz="1100" b="0" i="0">
+                <a:solidFill>
+                  <a:srgbClr val="CFE2F3"/>
+                </a:solidFill>
+                <a:latin typeface="Calibri"/>
+              </a:rPr>
+              <a:t>Covers the academic year</a:t>
+            </a:r>
+          </a:p>
+        </p:txBody>
+      </p:sp>
+      <p:sp>
+        <p:nvSpPr>
+          <p:cNvPr id="52" name="Rounded Rectangle 51"/>
+          <p:cNvSpPr/>
+          <p:nvPr/>
+        </p:nvSpPr>
+        <p:spPr>
+          <a:xfrm>
+            <a:off x="3606850" y="2423160"/>
+            <a:ext cx="1005840" cy="237744"/>
+          </a:xfrm>
+          <a:prstGeom prst="roundRect">
+            <a:avLst>
+              <a:gd name="adj" fmla="val 50000"/>
+            </a:avLst>
+          </a:prstGeom>
+          <a:solidFill>
+            <a:srgbClr val="4FD1C5"/>
+          </a:solidFill>
+          <a:ln>
+            <a:noFill/>
+          </a:ln>
+        </p:spPr>
+        <p:style>
+          <a:lnRef idx="1">
+            <a:schemeClr val="accent1"/>
+          </a:lnRef>
+          <a:fillRef idx="3">
+            <a:schemeClr val="accent1"/>
+          </a:fillRef>
+          <a:effectRef idx="2">
+            <a:schemeClr val="accent1"/>
+          </a:effectRef>
+          <a:fontRef idx="minor">
+            <a:schemeClr val="lt1"/>
+          </a:fontRef>
+        </p:style>
+        <p:txBody>
+          <a:bodyPr rtlCol="0" anchor="ctr"/>
+          <a:lstStyle/>
+          <a:p/>
+        </p:txBody>
+      </p:sp>
+      <p:sp>
+        <p:nvSpPr>
+          <p:cNvPr id="53" name="TextBox 52"/>
+          <p:cNvSpPr txBox="1"/>
+          <p:nvPr/>
+        </p:nvSpPr>
+        <p:spPr>
+          <a:xfrm>
+            <a:off x="3606850" y="2423160"/>
+            <a:ext cx="1005840" cy="237744"/>
+          </a:xfrm>
+          <a:prstGeom prst="rect">
+            <a:avLst/>
+          </a:prstGeom>
+          <a:noFill/>
+        </p:spPr>
+        <p:txBody>
+          <a:bodyPr wrap="square" lIns="0" rIns="0" tIns="0" bIns="0" anchor="ctr">
+            <a:spAutoFit/>
+          </a:bodyPr>
+          <a:lstStyle/>
+          <a:p>
+            <a:pPr algn="ctr"/>
+            <a:r>
+              <a:rPr sz="900" b="1" i="0" spc="150">
+                <a:solidFill>
+                  <a:srgbClr val="0B2238"/>
+                </a:solidFill>
+                <a:latin typeface="Calibri"/>
+              </a:rPr>
+              <a:t>BEST VALUE</a:t>
+            </a:r>
+          </a:p>
+        </p:txBody>
+      </p:sp>
+      <p:sp>
+        <p:nvSpPr>
+          <p:cNvPr id="54" name="Rounded Rectangle 53"/>
+          <p:cNvSpPr/>
+          <p:nvPr/>
+        </p:nvSpPr>
+        <p:spPr>
+          <a:xfrm>
+            <a:off x="5363870" y="2542032"/>
+            <a:ext cx="2197303" cy="2670048"/>
+          </a:xfrm>
+          <a:prstGeom prst="roundRect">
+            <a:avLst>
+              <a:gd name="adj" fmla="val 6000"/>
+            </a:avLst>
+          </a:prstGeom>
+          <a:solidFill>
+            <a:srgbClr val="FFFFFF"/>
+          </a:solidFill>
+          <a:ln w="12700">
+            <a:solidFill>
+              <a:srgbClr val="D4E2EE"/>
+            </a:solidFill>
+          </a:ln>
+          <a:effectLst>
+            <a:outerShdw blurRad="177800" dist="38100" dir="5400000" algn="bl" rotWithShape="0">
+              <a:srgbClr val="0B2238">
+                <a:alpha val="13000"/>
+              </a:srgbClr>
+            </a:outerShdw>
+          </a:effectLst>
+        </p:spPr>
+        <p:style>
+          <a:lnRef idx="1">
+            <a:schemeClr val="accent1"/>
+          </a:lnRef>
+          <a:fillRef idx="3">
+            <a:schemeClr val="accent1"/>
+          </a:fillRef>
+          <a:effectRef idx="2">
+            <a:schemeClr val="accent1"/>
+          </a:effectRef>
+          <a:fontRef idx="minor">
+            <a:schemeClr val="lt1"/>
+          </a:fontRef>
+        </p:style>
+        <p:txBody>
+          <a:bodyPr rtlCol="0" anchor="ctr"/>
+          <a:lstStyle/>
+          <a:p/>
+        </p:txBody>
+      </p:sp>
+      <p:sp>
+        <p:nvSpPr>
+          <p:cNvPr id="55" name="TextBox 54"/>
+          <p:cNvSpPr txBox="1"/>
+          <p:nvPr/>
+        </p:nvSpPr>
+        <p:spPr>
+          <a:xfrm>
+            <a:off x="5565038" y="2761487"/>
+            <a:ext cx="1794967" cy="219456"/>
+          </a:xfrm>
+          <a:prstGeom prst="rect">
+            <a:avLst/>
+          </a:prstGeom>
+          <a:noFill/>
+        </p:spPr>
+        <p:txBody>
+          <a:bodyPr wrap="square" lIns="0" rIns="0" tIns="0" bIns="0" anchor="t">
+            <a:spAutoFit/>
+          </a:bodyPr>
+          <a:lstStyle/>
+          <a:p>
+            <a:pPr algn="l"/>
+            <a:r>
+              <a:rPr sz="1000" b="1" i="0" spc="150">
+                <a:solidFill>
+                  <a:srgbClr val="0F4C81"/>
+                </a:solidFill>
+                <a:latin typeface="Calibri"/>
+              </a:rPr>
+              <a:t>INSTRUCTOR</a:t>
+            </a:r>
+          </a:p>
+        </p:txBody>
+      </p:sp>
+      <p:sp>
+        <p:nvSpPr>
+          <p:cNvPr id="56" name="TextBox 55"/>
+          <p:cNvSpPr txBox="1"/>
+          <p:nvPr/>
+        </p:nvSpPr>
+        <p:spPr>
+          <a:xfrm>
+            <a:off x="5565038" y="2999232"/>
+            <a:ext cx="1794967" cy="548640"/>
+          </a:xfrm>
+          <a:prstGeom prst="rect">
+            <a:avLst/>
+          </a:prstGeom>
+          <a:noFill/>
+        </p:spPr>
+        <p:txBody>
+          <a:bodyPr wrap="square" lIns="0" rIns="0" tIns="0" bIns="0" anchor="t">
+            <a:spAutoFit/>
+          </a:bodyPr>
+          <a:lstStyle/>
+          <a:p>
+            <a:pPr algn="l"/>
+            <a:r>
+              <a:rPr sz="3000" b="1" i="0">
+                <a:solidFill>
+                  <a:srgbClr val="0F4C81"/>
+                </a:solidFill>
+                <a:latin typeface="Calibri"/>
+              </a:rPr>
+              <a:t>$9.99</a:t>
+            </a:r>
+            <a:r>
+              <a:rPr sz="1200" b="0" i="0">
+                <a:solidFill>
+                  <a:srgbClr val="6B7A8C"/>
+                </a:solidFill>
+                <a:latin typeface="Calibri"/>
+              </a:rPr>
+              <a:t> / month</a:t>
+            </a:r>
+          </a:p>
+        </p:txBody>
+      </p:sp>
+      <p:sp>
+        <p:nvSpPr>
+          <p:cNvPr id="57" name="TextBox 56"/>
+          <p:cNvSpPr txBox="1"/>
+          <p:nvPr/>
+        </p:nvSpPr>
+        <p:spPr>
+          <a:xfrm>
+            <a:off x="5565038" y="3547872"/>
+            <a:ext cx="1794967" cy="237744"/>
+          </a:xfrm>
+          <a:prstGeom prst="rect">
+            <a:avLst/>
+          </a:prstGeom>
+          <a:noFill/>
+        </p:spPr>
+        <p:txBody>
+          <a:bodyPr wrap="square" lIns="0" rIns="0" tIns="0" bIns="0" anchor="t">
+            <a:spAutoFit/>
+          </a:bodyPr>
+          <a:lstStyle/>
+          <a:p>
+            <a:pPr algn="l"/>
+            <a:r>
+              <a:rPr sz="1050" b="0" i="1">
+                <a:solidFill>
+                  <a:srgbClr val="6B7A8C"/>
+                </a:solidFill>
+                <a:latin typeface="Calibri"/>
+              </a:rPr>
+              <a:t>30-day department pilot</a:t>
+            </a:r>
+          </a:p>
+        </p:txBody>
+      </p:sp>
+      <p:sp>
+        <p:nvSpPr>
+          <p:cNvPr id="58" name="Oval 57"/>
+          <p:cNvSpPr/>
+          <p:nvPr/>
+        </p:nvSpPr>
+        <p:spPr>
+          <a:xfrm>
+            <a:off x="5565038" y="4023360"/>
+            <a:ext cx="91440" cy="91440"/>
+          </a:xfrm>
+          <a:prstGeom prst="ellipse">
+            <a:avLst/>
+          </a:prstGeom>
+          <a:solidFill>
+            <a:srgbClr val="0F4C81"/>
+          </a:solidFill>
+          <a:ln>
+            <a:noFill/>
+          </a:ln>
+        </p:spPr>
+        <p:style>
+          <a:lnRef idx="1">
+            <a:schemeClr val="accent1"/>
+          </a:lnRef>
+          <a:fillRef idx="3">
+            <a:schemeClr val="accent1"/>
+          </a:fillRef>
+          <a:effectRef idx="2">
+            <a:schemeClr val="accent1"/>
+          </a:effectRef>
+          <a:fontRef idx="minor">
+            <a:schemeClr val="lt1"/>
+          </a:fontRef>
+        </p:style>
+        <p:txBody>
+          <a:bodyPr rtlCol="0" anchor="ctr"/>
+          <a:lstStyle/>
+          <a:p>
+            <a:pPr algn="ctr"/>
+          </a:p>
+        </p:txBody>
+      </p:sp>
+      <p:sp>
+        <p:nvSpPr>
+          <p:cNvPr id="59" name="TextBox 58"/>
+          <p:cNvSpPr txBox="1"/>
+          <p:nvPr/>
+        </p:nvSpPr>
+        <p:spPr>
+          <a:xfrm>
+            <a:off x="5747918" y="3959352"/>
+            <a:ext cx="1612087" cy="274320"/>
+          </a:xfrm>
+          <a:prstGeom prst="rect">
+            <a:avLst/>
+          </a:prstGeom>
+          <a:noFill/>
+        </p:spPr>
+        <p:txBody>
+          <a:bodyPr wrap="square" lIns="0" rIns="0" tIns="0" bIns="0" anchor="t">
+            <a:spAutoFit/>
+          </a:bodyPr>
+          <a:lstStyle/>
+          <a:p>
+            <a:pPr algn="l"/>
+            <a:r>
+              <a:rPr sz="1100" b="0" i="0">
+                <a:solidFill>
+                  <a:srgbClr val="0F1620"/>
+                </a:solidFill>
+                <a:latin typeface="Calibri"/>
+              </a:rPr>
+              <a:t>Papers for a whole class</a:t>
+            </a:r>
+          </a:p>
+        </p:txBody>
+      </p:sp>
+      <p:sp>
+        <p:nvSpPr>
+          <p:cNvPr id="60" name="Oval 59"/>
+          <p:cNvSpPr/>
+          <p:nvPr/>
+        </p:nvSpPr>
+        <p:spPr>
+          <a:xfrm>
+            <a:off x="5565038" y="4389120"/>
+            <a:ext cx="91440" cy="91440"/>
+          </a:xfrm>
+          <a:prstGeom prst="ellipse">
+            <a:avLst/>
+          </a:prstGeom>
+          <a:solidFill>
+            <a:srgbClr val="0F4C81"/>
+          </a:solidFill>
+          <a:ln>
+            <a:noFill/>
+          </a:ln>
+        </p:spPr>
+        <p:style>
+          <a:lnRef idx="1">
+            <a:schemeClr val="accent1"/>
+          </a:lnRef>
+          <a:fillRef idx="3">
+            <a:schemeClr val="accent1"/>
+          </a:fillRef>
+          <a:effectRef idx="2">
+            <a:schemeClr val="accent1"/>
+          </a:effectRef>
+          <a:fontRef idx="minor">
+            <a:schemeClr val="lt1"/>
+          </a:fontRef>
+        </p:style>
+        <p:txBody>
+          <a:bodyPr rtlCol="0" anchor="ctr"/>
+          <a:lstStyle/>
+          <a:p>
+            <a:pPr algn="ctr"/>
+          </a:p>
+        </p:txBody>
+      </p:sp>
+      <p:sp>
+        <p:nvSpPr>
+          <p:cNvPr id="61" name="TextBox 60"/>
+          <p:cNvSpPr txBox="1"/>
+          <p:nvPr/>
+        </p:nvSpPr>
+        <p:spPr>
+          <a:xfrm>
+            <a:off x="5747918" y="4325112"/>
+            <a:ext cx="1612087" cy="274320"/>
+          </a:xfrm>
+          <a:prstGeom prst="rect">
+            <a:avLst/>
+          </a:prstGeom>
+          <a:noFill/>
+        </p:spPr>
+        <p:txBody>
+          <a:bodyPr wrap="square" lIns="0" rIns="0" tIns="0" bIns="0" anchor="t">
+            <a:spAutoFit/>
+          </a:bodyPr>
+          <a:lstStyle/>
+          <a:p>
+            <a:pPr algn="l"/>
+            <a:r>
+              <a:rPr sz="1100" b="0" i="0">
+                <a:solidFill>
+                  <a:srgbClr val="0F1620"/>
+                </a:solidFill>
+                <a:latin typeface="Calibri"/>
+              </a:rPr>
+              <a:t>Coverage report per paper</a:t>
+            </a:r>
+          </a:p>
+        </p:txBody>
+      </p:sp>
+      <p:sp>
+        <p:nvSpPr>
+          <p:cNvPr id="62" name="Oval 61"/>
+          <p:cNvSpPr/>
+          <p:nvPr/>
+        </p:nvSpPr>
+        <p:spPr>
+          <a:xfrm>
+            <a:off x="5565038" y="4754880"/>
+            <a:ext cx="91440" cy="91440"/>
+          </a:xfrm>
+          <a:prstGeom prst="ellipse">
+            <a:avLst/>
+          </a:prstGeom>
+          <a:solidFill>
+            <a:srgbClr val="0F4C81"/>
+          </a:solidFill>
+          <a:ln>
+            <a:noFill/>
+          </a:ln>
+        </p:spPr>
+        <p:style>
+          <a:lnRef idx="1">
+            <a:schemeClr val="accent1"/>
+          </a:lnRef>
+          <a:fillRef idx="3">
+            <a:schemeClr val="accent1"/>
+          </a:fillRef>
+          <a:effectRef idx="2">
+            <a:schemeClr val="accent1"/>
+          </a:effectRef>
+          <a:fontRef idx="minor">
+            <a:schemeClr val="lt1"/>
+          </a:fontRef>
+        </p:style>
+        <p:txBody>
+          <a:bodyPr rtlCol="0" anchor="ctr"/>
+          <a:lstStyle/>
+          <a:p>
+            <a:pPr algn="ctr"/>
+          </a:p>
+        </p:txBody>
+      </p:sp>
+      <p:sp>
+        <p:nvSpPr>
+          <p:cNvPr id="63" name="TextBox 62"/>
+          <p:cNvSpPr txBox="1"/>
+          <p:nvPr/>
+        </p:nvSpPr>
+        <p:spPr>
+          <a:xfrm>
+            <a:off x="5747918" y="4690872"/>
+            <a:ext cx="1612087" cy="274320"/>
+          </a:xfrm>
+          <a:prstGeom prst="rect">
+            <a:avLst/>
+          </a:prstGeom>
+          <a:noFill/>
+        </p:spPr>
+        <p:txBody>
+          <a:bodyPr wrap="square" lIns="0" rIns="0" tIns="0" bIns="0" anchor="t">
+            <a:spAutoFit/>
+          </a:bodyPr>
+          <a:lstStyle/>
+          <a:p>
+            <a:pPr algn="l"/>
+            <a:r>
+              <a:rPr sz="1100" b="0" i="0">
+                <a:solidFill>
+                  <a:srgbClr val="0F1620"/>
+                </a:solidFill>
+                <a:latin typeface="Calibri"/>
+              </a:rPr>
+              <a:t>Grader as it ships</a:t>
+            </a:r>
+          </a:p>
+        </p:txBody>
+      </p:sp>
+      <p:sp>
+        <p:nvSpPr>
+          <p:cNvPr id="64" name="TextBox 63"/>
+          <p:cNvSpPr txBox="1"/>
+          <p:nvPr/>
+        </p:nvSpPr>
+        <p:spPr>
+          <a:xfrm>
+            <a:off x="7818120" y="1755648"/>
+            <a:ext cx="3721608" cy="256032"/>
+          </a:xfrm>
+          <a:prstGeom prst="rect">
+            <a:avLst/>
+          </a:prstGeom>
+          <a:noFill/>
+        </p:spPr>
+        <p:txBody>
+          <a:bodyPr wrap="square" lIns="0" rIns="0" tIns="0" bIns="0" anchor="t">
+            <a:spAutoFit/>
+          </a:bodyPr>
+          <a:lstStyle/>
+          <a:p>
+            <a:pPr algn="l"/>
+            <a:r>
+              <a:rPr sz="1100" b="1" i="0" spc="300">
+                <a:solidFill>
+                  <a:srgbClr val="0F4C81"/>
+                </a:solidFill>
+                <a:latin typeface="Calibri"/>
+              </a:rPr>
+              <a:t>BENCHMARKED AGAINST</a:t>
+            </a:r>
+          </a:p>
+        </p:txBody>
+      </p:sp>
+      <p:sp>
+        <p:nvSpPr>
+          <p:cNvPr id="65" name="TextBox 64"/>
+          <p:cNvSpPr txBox="1"/>
+          <p:nvPr/>
+        </p:nvSpPr>
+        <p:spPr>
+          <a:xfrm>
+            <a:off x="7818120" y="2011680"/>
+            <a:ext cx="3721608" cy="228600"/>
+          </a:xfrm>
+          <a:prstGeom prst="rect">
+            <a:avLst/>
+          </a:prstGeom>
+          <a:noFill/>
+        </p:spPr>
+        <p:txBody>
+          <a:bodyPr wrap="square" lIns="0" rIns="0" tIns="0" bIns="0" anchor="t">
+            <a:spAutoFit/>
+          </a:bodyPr>
+          <a:lstStyle/>
+          <a:p>
+            <a:pPr algn="l"/>
+            <a:r>
+              <a:rPr sz="1050" b="0" i="1">
+                <a:solidFill>
+                  <a:srgbClr val="6B7A8C"/>
+                </a:solidFill>
+                <a:latin typeface="Calibri"/>
+              </a:rPr>
+              <a:t>reported prices, October 2026</a:t>
+            </a:r>
+          </a:p>
+        </p:txBody>
+      </p:sp>
+      <p:graphicFrame>
+        <p:nvGraphicFramePr>
+          <p:cNvPr id="66" name="Table 65"/>
+          <p:cNvGraphicFramePr>
+            <a:graphicFrameLocks noGrp="1"/>
+          </p:cNvGraphicFramePr>
+          <p:nvPr/>
+        </p:nvGraphicFramePr>
+        <p:xfrm>
+          <a:off x="7818120" y="2331720"/>
+          <a:ext cx="3721608" cy="2432304"/>
+        </p:xfrm>
+        <a:graphic>
+          <a:graphicData uri="http://schemas.openxmlformats.org/drawingml/2006/table">
+            <a:tbl>
+              <a:tblPr firstRow="1">
+                <a:tableStyleId>{5C22544A-7EE6-4342-B048-85BDC9FD1C3A}</a:tableStyleId>
+              </a:tblPr>
+              <a:tblGrid>
+                <a:gridCol w="1325880"/>
+                <a:gridCol w="713232"/>
+                <a:gridCol w="841248"/>
+                <a:gridCol w="841248"/>
+              </a:tblGrid>
+              <a:tr h="347472">
+                <a:tc>
+                  <a:txBody>
+                    <a:bodyPr/>
+                    <a:lstStyle/>
+                    <a:p>
+                      <a:r>
+                        <a:rPr sz="1050" b="1">
+                          <a:solidFill>
+                            <a:srgbClr val="FFFFFF"/>
+                          </a:solidFill>
+                          <a:latin typeface="Calibri"/>
+                        </a:rPr>
+                        <a:t/>
+                      </a:r>
+                    </a:p>
+                  </a:txBody>
+                  <a:tcPr marL="73152" marR="73152" marT="27432" marB="27432" anchor="ctr">
+                    <a:solidFill>
+                      <a:srgbClr val="0F4C81"/>
+                    </a:solidFill>
+                  </a:tcPr>
+                </a:tc>
+                <a:tc>
+                  <a:txBody>
+                    <a:bodyPr/>
+                    <a:lstStyle/>
+                    <a:p>
+                      <a:r>
+                        <a:rPr sz="1050" b="1">
+                          <a:solidFill>
+                            <a:srgbClr val="FFFFFF"/>
+                          </a:solidFill>
+                          <a:latin typeface="Calibri"/>
+                        </a:rPr>
+                        <a:t>Monthly</a:t>
+                      </a:r>
+                    </a:p>
+                  </a:txBody>
+                  <a:tcPr marL="73152" marR="73152" marT="27432" marB="27432" anchor="ctr">
+                    <a:solidFill>
+                      <a:srgbClr val="0F4C81"/>
+                    </a:solidFill>
+                  </a:tcPr>
+                </a:tc>
+                <a:tc>
+                  <a:txBody>
+                    <a:bodyPr/>
+                    <a:lstStyle/>
+                    <a:p>
+                      <a:r>
+                        <a:rPr sz="1050" b="1">
+                          <a:solidFill>
+                            <a:srgbClr val="FFFFFF"/>
+                          </a:solidFill>
+                          <a:latin typeface="Calibri"/>
+                        </a:rPr>
+                        <a:t>Annual</a:t>
+                      </a:r>
+                    </a:p>
+                  </a:txBody>
+                  <a:tcPr marL="73152" marR="73152" marT="27432" marB="27432" anchor="ctr">
+                    <a:solidFill>
+                      <a:srgbClr val="0F4C81"/>
+                    </a:solidFill>
+                  </a:tcPr>
+                </a:tc>
+                <a:tc>
+                  <a:txBody>
+                    <a:bodyPr/>
+                    <a:lstStyle/>
+                    <a:p>
+                      <a:r>
+                        <a:rPr sz="1050" b="1">
+                          <a:solidFill>
+                            <a:srgbClr val="FFFFFF"/>
+                          </a:solidFill>
+                          <a:latin typeface="Calibri"/>
+                        </a:rPr>
+                        <a:t>Trial</a:t>
+                      </a:r>
+                    </a:p>
+                  </a:txBody>
+                  <a:tcPr marL="73152" marR="73152" marT="27432" marB="27432" anchor="ctr">
+                    <a:solidFill>
+                      <a:srgbClr val="0F4C81"/>
+                    </a:solidFill>
+                  </a:tcPr>
+                </a:tc>
+              </a:tr>
+              <a:tr h="347472">
+                <a:tc>
+                  <a:txBody>
+                    <a:bodyPr/>
+                    <a:lstStyle/>
+                    <a:p>
+                      <a:r>
+                        <a:rPr sz="1050" b="1">
+                          <a:solidFill>
+                            <a:srgbClr val="0F1620"/>
+                          </a:solidFill>
+                          <a:latin typeface="Calibri"/>
+                        </a:rPr>
+                        <a:t>Quizlet Plus</a:t>
+                      </a:r>
+                    </a:p>
+                  </a:txBody>
+                  <a:tcPr marL="73152" marR="73152" marT="27432" marB="27432" anchor="ctr">
+                    <a:solidFill>
+                      <a:srgbClr val="FFFFFF"/>
+                    </a:solidFill>
+                  </a:tcPr>
+                </a:tc>
+                <a:tc>
+                  <a:txBody>
+                    <a:bodyPr/>
+                    <a:lstStyle/>
+                    <a:p>
+                      <a:r>
+                        <a:rPr sz="1050" b="0">
+                          <a:solidFill>
+                            <a:srgbClr val="0F1620"/>
+                          </a:solidFill>
+                          <a:latin typeface="Calibri"/>
+                        </a:rPr>
+                        <a:t>$7.99</a:t>
+                      </a:r>
+                    </a:p>
+                  </a:txBody>
+                  <a:tcPr marL="73152" marR="73152" marT="27432" marB="27432" anchor="ctr">
+                    <a:solidFill>
+                      <a:srgbClr val="FFFFFF"/>
+                    </a:solidFill>
+                  </a:tcPr>
+                </a:tc>
+                <a:tc>
+                  <a:txBody>
+                    <a:bodyPr/>
+                    <a:lstStyle/>
+                    <a:p>
+                      <a:r>
+                        <a:rPr sz="1050" b="0">
+                          <a:solidFill>
+                            <a:srgbClr val="0F1620"/>
+                          </a:solidFill>
+                          <a:latin typeface="Calibri"/>
+                        </a:rPr>
+                        <a:t>$35.99</a:t>
+                      </a:r>
+                    </a:p>
+                  </a:txBody>
+                  <a:tcPr marL="73152" marR="73152" marT="27432" marB="27432" anchor="ctr">
+                    <a:solidFill>
+                      <a:srgbClr val="FFFFFF"/>
+                    </a:solidFill>
+                  </a:tcPr>
+                </a:tc>
+                <a:tc>
+                  <a:txBody>
+                    <a:bodyPr/>
+                    <a:lstStyle/>
+                    <a:p>
+                      <a:r>
+                        <a:rPr sz="1050" b="0">
+                          <a:solidFill>
+                            <a:srgbClr val="0F1620"/>
+                          </a:solidFill>
+                          <a:latin typeface="Calibri"/>
+                        </a:rPr>
+                        <a:t>7 days*</a:t>
+                      </a:r>
+                    </a:p>
+                  </a:txBody>
+                  <a:tcPr marL="73152" marR="73152" marT="27432" marB="27432" anchor="ctr">
+                    <a:solidFill>
+                      <a:srgbClr val="FFFFFF"/>
+                    </a:solidFill>
+                  </a:tcPr>
+                </a:tc>
+              </a:tr>
+              <a:tr h="347472">
+                <a:tc>
+                  <a:txBody>
+                    <a:bodyPr/>
+                    <a:lstStyle/>
+                    <a:p>
+                      <a:r>
+                        <a:rPr sz="1050" b="1">
+                          <a:solidFill>
+                            <a:srgbClr val="0F1620"/>
+                          </a:solidFill>
+                          <a:latin typeface="Calibri"/>
+                        </a:rPr>
+                        <a:t>StudyFetch</a:t>
+                      </a:r>
+                    </a:p>
+                  </a:txBody>
+                  <a:tcPr marL="73152" marR="73152" marT="27432" marB="27432" anchor="ctr">
+                    <a:solidFill>
+                      <a:srgbClr val="F6F9FC"/>
+                    </a:solidFill>
+                  </a:tcPr>
+                </a:tc>
+                <a:tc>
+                  <a:txBody>
+                    <a:bodyPr/>
+                    <a:lstStyle/>
+                    <a:p>
+                      <a:r>
+                        <a:rPr sz="1050" b="0">
+                          <a:solidFill>
+                            <a:srgbClr val="0F1620"/>
+                          </a:solidFill>
+                          <a:latin typeface="Calibri"/>
+                        </a:rPr>
+                        <a:t>$11.99</a:t>
+                      </a:r>
+                    </a:p>
+                  </a:txBody>
+                  <a:tcPr marL="73152" marR="73152" marT="27432" marB="27432" anchor="ctr">
+                    <a:solidFill>
+                      <a:srgbClr val="F6F9FC"/>
+                    </a:solidFill>
+                  </a:tcPr>
+                </a:tc>
+                <a:tc>
+                  <a:txBody>
+                    <a:bodyPr/>
+                    <a:lstStyle/>
+                    <a:p>
+                      <a:r>
+                        <a:rPr sz="1050" b="0">
+                          <a:solidFill>
+                            <a:srgbClr val="0F1620"/>
+                          </a:solidFill>
+                          <a:latin typeface="Calibri"/>
+                        </a:rPr>
+                        <a:t>$99.99</a:t>
+                      </a:r>
+                    </a:p>
+                  </a:txBody>
+                  <a:tcPr marL="73152" marR="73152" marT="27432" marB="27432" anchor="ctr">
+                    <a:solidFill>
+                      <a:srgbClr val="F6F9FC"/>
+                    </a:solidFill>
+                  </a:tcPr>
+                </a:tc>
+                <a:tc>
+                  <a:txBody>
+                    <a:bodyPr/>
+                    <a:lstStyle/>
+                    <a:p>
+                      <a:r>
+                        <a:rPr sz="1050" b="0">
+                          <a:solidFill>
+                            <a:srgbClr val="0F1620"/>
+                          </a:solidFill>
+                          <a:latin typeface="Calibri"/>
+                        </a:rPr>
+                        <a:t>7 days</a:t>
+                      </a:r>
+                    </a:p>
+                  </a:txBody>
+                  <a:tcPr marL="73152" marR="73152" marT="27432" marB="27432" anchor="ctr">
+                    <a:solidFill>
+                      <a:srgbClr val="F6F9FC"/>
+                    </a:solidFill>
+                  </a:tcPr>
+                </a:tc>
+              </a:tr>
+              <a:tr h="347472">
+                <a:tc>
+                  <a:txBody>
+                    <a:bodyPr/>
+                    <a:lstStyle/>
+                    <a:p>
+                      <a:r>
+                        <a:rPr sz="1050" b="1">
+                          <a:solidFill>
+                            <a:srgbClr val="0F1620"/>
+                          </a:solidFill>
+                          <a:latin typeface="Calibri"/>
+                        </a:rPr>
+                        <a:t>Chegg Study</a:t>
+                      </a:r>
+                    </a:p>
+                  </a:txBody>
+                  <a:tcPr marL="73152" marR="73152" marT="27432" marB="27432" anchor="ctr">
+                    <a:solidFill>
+                      <a:srgbClr val="FFFFFF"/>
+                    </a:solidFill>
+                  </a:tcPr>
+                </a:tc>
+                <a:tc>
+                  <a:txBody>
+                    <a:bodyPr/>
+                    <a:lstStyle/>
+                    <a:p>
+                      <a:r>
+                        <a:rPr sz="1050" b="0">
+                          <a:solidFill>
+                            <a:srgbClr val="0F1620"/>
+                          </a:solidFill>
+                          <a:latin typeface="Calibri"/>
+                        </a:rPr>
+                        <a:t>$15.95</a:t>
+                      </a:r>
+                    </a:p>
+                  </a:txBody>
+                  <a:tcPr marL="73152" marR="73152" marT="27432" marB="27432" anchor="ctr">
+                    <a:solidFill>
+                      <a:srgbClr val="FFFFFF"/>
+                    </a:solidFill>
+                  </a:tcPr>
+                </a:tc>
+                <a:tc>
+                  <a:txBody>
+                    <a:bodyPr/>
+                    <a:lstStyle/>
+                    <a:p>
+                      <a:r>
+                        <a:rPr sz="1050" b="0">
+                          <a:solidFill>
+                            <a:srgbClr val="0F1620"/>
+                          </a:solidFill>
+                          <a:latin typeface="Calibri"/>
+                        </a:rPr>
+                        <a:t>—</a:t>
+                      </a:r>
+                    </a:p>
+                  </a:txBody>
+                  <a:tcPr marL="73152" marR="73152" marT="27432" marB="27432" anchor="ctr">
+                    <a:solidFill>
+                      <a:srgbClr val="FFFFFF"/>
+                    </a:solidFill>
+                  </a:tcPr>
+                </a:tc>
+                <a:tc>
+                  <a:txBody>
+                    <a:bodyPr/>
+                    <a:lstStyle/>
+                    <a:p>
+                      <a:r>
+                        <a:rPr sz="1050" b="0">
+                          <a:solidFill>
+                            <a:srgbClr val="0F1620"/>
+                          </a:solidFill>
+                          <a:latin typeface="Calibri"/>
+                        </a:rPr>
+                        <a:t>7 days</a:t>
+                      </a:r>
+                    </a:p>
+                  </a:txBody>
+                  <a:tcPr marL="73152" marR="73152" marT="27432" marB="27432" anchor="ctr">
+                    <a:solidFill>
+                      <a:srgbClr val="FFFFFF"/>
+                    </a:solidFill>
+                  </a:tcPr>
+                </a:tc>
+              </a:tr>
+              <a:tr h="347472">
+                <a:tc>
+                  <a:txBody>
+                    <a:bodyPr/>
+                    <a:lstStyle/>
+                    <a:p>
+                      <a:r>
+                        <a:rPr sz="1050" b="1">
+                          <a:solidFill>
+                            <a:srgbClr val="0F1620"/>
+                          </a:solidFill>
+                          <a:latin typeface="Calibri"/>
+                        </a:rPr>
+                        <a:t>Quizgecko</a:t>
+                      </a:r>
+                    </a:p>
+                  </a:txBody>
+                  <a:tcPr marL="73152" marR="73152" marT="27432" marB="27432" anchor="ctr">
+                    <a:solidFill>
+                      <a:srgbClr val="F6F9FC"/>
+                    </a:solidFill>
+                  </a:tcPr>
+                </a:tc>
+                <a:tc>
+                  <a:txBody>
+                    <a:bodyPr/>
+                    <a:lstStyle/>
+                    <a:p>
+                      <a:r>
+                        <a:rPr sz="1050" b="0">
+                          <a:solidFill>
+                            <a:srgbClr val="0F1620"/>
+                          </a:solidFill>
+                          <a:latin typeface="Calibri"/>
+                        </a:rPr>
+                        <a:t>$16</a:t>
+                      </a:r>
+                    </a:p>
+                  </a:txBody>
+                  <a:tcPr marL="73152" marR="73152" marT="27432" marB="27432" anchor="ctr">
+                    <a:solidFill>
+                      <a:srgbClr val="F6F9FC"/>
+                    </a:solidFill>
+                  </a:tcPr>
+                </a:tc>
+                <a:tc>
+                  <a:txBody>
+                    <a:bodyPr/>
+                    <a:lstStyle/>
+                    <a:p>
+                      <a:r>
+                        <a:rPr sz="1050" b="0">
+                          <a:solidFill>
+                            <a:srgbClr val="0F1620"/>
+                          </a:solidFill>
+                          <a:latin typeface="Calibri"/>
+                        </a:rPr>
+                        <a:t>—</a:t>
+                      </a:r>
+                    </a:p>
+                  </a:txBody>
+                  <a:tcPr marL="73152" marR="73152" marT="27432" marB="27432" anchor="ctr">
+                    <a:solidFill>
+                      <a:srgbClr val="F6F9FC"/>
+                    </a:solidFill>
+                  </a:tcPr>
+                </a:tc>
+                <a:tc>
+                  <a:txBody>
+                    <a:bodyPr/>
+                    <a:lstStyle/>
+                    <a:p>
+                      <a:r>
+                        <a:rPr sz="1050" b="0">
+                          <a:solidFill>
+                            <a:srgbClr val="0F1620"/>
+                          </a:solidFill>
+                          <a:latin typeface="Calibri"/>
+                        </a:rPr>
+                        <a:t>—</a:t>
+                      </a:r>
+                    </a:p>
+                  </a:txBody>
+                  <a:tcPr marL="73152" marR="73152" marT="27432" marB="27432" anchor="ctr">
+                    <a:solidFill>
+                      <a:srgbClr val="F6F9FC"/>
+                    </a:solidFill>
+                  </a:tcPr>
+                </a:tc>
+              </a:tr>
+              <a:tr h="347472">
+                <a:tc>
+                  <a:txBody>
+                    <a:bodyPr/>
+                    <a:lstStyle/>
+                    <a:p>
+                      <a:r>
+                        <a:rPr sz="1050" b="1">
+                          <a:solidFill>
+                            <a:srgbClr val="0F1620"/>
+                          </a:solidFill>
+                          <a:latin typeface="Calibri"/>
+                        </a:rPr>
+                        <a:t>Maqsad (PK) †</a:t>
+                      </a:r>
+                    </a:p>
+                  </a:txBody>
+                  <a:tcPr marL="73152" marR="73152" marT="27432" marB="27432" anchor="ctr">
+                    <a:solidFill>
+                      <a:srgbClr val="FFFFFF"/>
+                    </a:solidFill>
+                  </a:tcPr>
+                </a:tc>
+                <a:tc>
+                  <a:txBody>
+                    <a:bodyPr/>
+                    <a:lstStyle/>
+                    <a:p>
+                      <a:r>
+                        <a:rPr sz="1050" b="0">
+                          <a:solidFill>
+                            <a:srgbClr val="0F1620"/>
+                          </a:solidFill>
+                          <a:latin typeface="Calibri"/>
+                        </a:rPr>
+                        <a:t>≈ $4</a:t>
+                      </a:r>
+                    </a:p>
+                  </a:txBody>
+                  <a:tcPr marL="73152" marR="73152" marT="27432" marB="27432" anchor="ctr">
+                    <a:solidFill>
+                      <a:srgbClr val="FFFFFF"/>
+                    </a:solidFill>
+                  </a:tcPr>
+                </a:tc>
+                <a:tc>
+                  <a:txBody>
+                    <a:bodyPr/>
+                    <a:lstStyle/>
+                    <a:p>
+                      <a:r>
+                        <a:rPr sz="1050" b="0">
+                          <a:solidFill>
+                            <a:srgbClr val="0F1620"/>
+                          </a:solidFill>
+                          <a:latin typeface="Calibri"/>
+                        </a:rPr>
+                        <a:t>Rs 7,500</a:t>
+                      </a:r>
+                    </a:p>
+                  </a:txBody>
+                  <a:tcPr marL="73152" marR="73152" marT="27432" marB="27432" anchor="ctr">
+                    <a:solidFill>
+                      <a:srgbClr val="FFFFFF"/>
+                    </a:solidFill>
+                  </a:tcPr>
+                </a:tc>
+                <a:tc>
+                  <a:txBody>
+                    <a:bodyPr/>
+                    <a:lstStyle/>
+                    <a:p>
+                      <a:r>
+                        <a:rPr sz="1050" b="0">
+                          <a:solidFill>
+                            <a:srgbClr val="0F1620"/>
+                          </a:solidFill>
+                          <a:latin typeface="Calibri"/>
+                        </a:rPr>
+                        <a:t>free class</a:t>
+                      </a:r>
+                    </a:p>
+                  </a:txBody>
+                  <a:tcPr marL="73152" marR="73152" marT="27432" marB="27432" anchor="ctr">
+                    <a:solidFill>
+                      <a:srgbClr val="FFFFFF"/>
+                    </a:solidFill>
+                  </a:tcPr>
+                </a:tc>
+              </a:tr>
+              <a:tr h="347472">
+                <a:tc>
+                  <a:txBody>
+                    <a:bodyPr/>
+                    <a:lstStyle/>
+                    <a:p>
+                      <a:r>
+                        <a:rPr sz="1050" b="1">
+                          <a:solidFill>
+                            <a:srgbClr val="0F4C81"/>
+                          </a:solidFill>
+                          <a:latin typeface="Calibri"/>
+                        </a:rPr>
+                        <a:t>Prepify</a:t>
+                      </a:r>
+                    </a:p>
+                  </a:txBody>
+                  <a:tcPr marL="73152" marR="73152" marT="27432" marB="27432" anchor="ctr">
+                    <a:solidFill>
+                      <a:srgbClr val="E3EEF8"/>
+                    </a:solidFill>
+                  </a:tcPr>
+                </a:tc>
+                <a:tc>
+                  <a:txBody>
+                    <a:bodyPr/>
+                    <a:lstStyle/>
+                    <a:p>
+                      <a:r>
+                        <a:rPr sz="1050" b="1">
+                          <a:solidFill>
+                            <a:srgbClr val="0F4C81"/>
+                          </a:solidFill>
+                          <a:latin typeface="Calibri"/>
+                        </a:rPr>
+                        <a:t>$5.99</a:t>
+                      </a:r>
+                    </a:p>
+                  </a:txBody>
+                  <a:tcPr marL="73152" marR="73152" marT="27432" marB="27432" anchor="ctr">
+                    <a:solidFill>
+                      <a:srgbClr val="E3EEF8"/>
+                    </a:solidFill>
+                  </a:tcPr>
+                </a:tc>
+                <a:tc>
+                  <a:txBody>
+                    <a:bodyPr/>
+                    <a:lstStyle/>
+                    <a:p>
+                      <a:r>
+                        <a:rPr sz="1050" b="1">
+                          <a:solidFill>
+                            <a:srgbClr val="0F4C81"/>
+                          </a:solidFill>
+                          <a:latin typeface="Calibri"/>
+                        </a:rPr>
+                        <a:t>$39.99</a:t>
+                      </a:r>
+                    </a:p>
+                  </a:txBody>
+                  <a:tcPr marL="73152" marR="73152" marT="27432" marB="27432" anchor="ctr">
+                    <a:solidFill>
+                      <a:srgbClr val="E3EEF8"/>
+                    </a:solidFill>
+                  </a:tcPr>
+                </a:tc>
+                <a:tc>
+                  <a:txBody>
+                    <a:bodyPr/>
+                    <a:lstStyle/>
+                    <a:p>
+                      <a:r>
+                        <a:rPr sz="1050" b="1">
+                          <a:solidFill>
+                            <a:srgbClr val="0F4C81"/>
+                          </a:solidFill>
+                          <a:latin typeface="Calibri"/>
+                        </a:rPr>
+                        <a:t>7 days</a:t>
+                      </a:r>
+                    </a:p>
+                  </a:txBody>
+                  <a:tcPr marL="73152" marR="73152" marT="27432" marB="27432" anchor="ctr">
+                    <a:solidFill>
+                      <a:srgbClr val="E3EEF8"/>
+                    </a:solidFill>
+                  </a:tcPr>
+                </a:tc>
+              </a:tr>
+            </a:tbl>
+          </a:graphicData>
+        </a:graphic>
+      </p:graphicFrame>
+      <p:sp>
+        <p:nvSpPr>
+          <p:cNvPr id="67" name="TextBox 66"/>
+          <p:cNvSpPr txBox="1"/>
+          <p:nvPr/>
+        </p:nvSpPr>
+        <p:spPr>
+          <a:xfrm>
+            <a:off x="7818120" y="4837176"/>
+            <a:ext cx="3721608" cy="457200"/>
+          </a:xfrm>
+          <a:prstGeom prst="rect">
+            <a:avLst/>
+          </a:prstGeom>
+          <a:noFill/>
+        </p:spPr>
+        <p:txBody>
+          <a:bodyPr wrap="square" lIns="0" rIns="0" tIns="0" bIns="0" anchor="t">
+            <a:spAutoFit/>
+          </a:bodyPr>
+          <a:lstStyle/>
+          <a:p>
+            <a:pPr algn="l"/>
+            <a:r>
+              <a:rPr sz="900" b="0" i="1">
+                <a:solidFill>
+                  <a:srgbClr val="6B7A8C"/>
+                </a:solidFill>
+                <a:latin typeface="Calibri"/>
+              </a:rPr>
+              <a:t>* Quizlet's trial applies to annual plans only.  † Undated listing; Rs 7,500 is a year-long prep batch. Third-party listings — official pricing pages could not be verified.</a:t>
+            </a:r>
+          </a:p>
+        </p:txBody>
+      </p:sp>
+      <p:sp>
+        <p:nvSpPr>
+          <p:cNvPr id="68" name="Rounded Rectangle 67"/>
+          <p:cNvSpPr/>
+          <p:nvPr/>
+        </p:nvSpPr>
+        <p:spPr>
+          <a:xfrm>
+            <a:off x="658368" y="5413248"/>
+            <a:ext cx="10881360" cy="566928"/>
+          </a:xfrm>
+          <a:prstGeom prst="roundRect">
+            <a:avLst>
+              <a:gd name="adj" fmla="val 12000"/>
+            </a:avLst>
+          </a:prstGeom>
+          <a:solidFill>
+            <a:srgbClr val="F4F9FD"/>
+          </a:solidFill>
+          <a:ln w="12700">
+            <a:solidFill>
+              <a:srgbClr val="D4E2EE"/>
+            </a:solidFill>
+          </a:ln>
+        </p:spPr>
+        <p:style>
+          <a:lnRef idx="1">
+            <a:schemeClr val="accent1"/>
+          </a:lnRef>
+          <a:fillRef idx="3">
+            <a:schemeClr val="accent1"/>
+          </a:fillRef>
+          <a:effectRef idx="2">
+            <a:schemeClr val="accent1"/>
+          </a:effectRef>
+          <a:fontRef idx="minor">
+            <a:schemeClr val="lt1"/>
+          </a:fontRef>
+        </p:style>
+        <p:txBody>
+          <a:bodyPr rtlCol="0" anchor="ctr"/>
+          <a:lstStyle/>
+          <a:p/>
+        </p:txBody>
+      </p:sp>
+      <p:sp>
+        <p:nvSpPr>
+          <p:cNvPr id="69" name="TextBox 68"/>
+          <p:cNvSpPr txBox="1"/>
+          <p:nvPr/>
+        </p:nvSpPr>
+        <p:spPr>
+          <a:xfrm>
+            <a:off x="868680" y="5413248"/>
+            <a:ext cx="1005840" cy="566928"/>
+          </a:xfrm>
+          <a:prstGeom prst="rect">
+            <a:avLst/>
+          </a:prstGeom>
+          <a:noFill/>
+        </p:spPr>
+        <p:txBody>
+          <a:bodyPr wrap="square" lIns="0" rIns="0" tIns="0" bIns="0" anchor="ctr">
+            <a:spAutoFit/>
+          </a:bodyPr>
+          <a:lstStyle/>
+          <a:p>
+            <a:pPr algn="l"/>
+            <a:r>
+              <a:rPr sz="1000" b="1" i="0" spc="200">
+                <a:solidFill>
+                  <a:srgbClr val="0F4C81"/>
+                </a:solidFill>
+                <a:latin typeface="Calibri"/>
+              </a:rPr>
+              <a:t>UNIT COST</a:t>
+            </a:r>
+          </a:p>
+        </p:txBody>
+      </p:sp>
+      <p:sp>
+        <p:nvSpPr>
+          <p:cNvPr id="70" name="TextBox 69"/>
+          <p:cNvSpPr txBox="1"/>
+          <p:nvPr/>
+        </p:nvSpPr>
+        <p:spPr>
+          <a:xfrm>
+            <a:off x="1874519" y="5413248"/>
+            <a:ext cx="4160520" cy="566928"/>
+          </a:xfrm>
+          <a:prstGeom prst="rect">
+            <a:avLst/>
+          </a:prstGeom>
+          <a:noFill/>
+        </p:spPr>
+        <p:txBody>
+          <a:bodyPr wrap="square" lIns="0" rIns="0" tIns="0" bIns="0" anchor="ctr">
+            <a:spAutoFit/>
+          </a:bodyPr>
+          <a:lstStyle/>
+          <a:p>
+            <a:pPr algn="l"/>
+            <a:r>
+              <a:rPr sz="1100" b="0" i="0">
+                <a:solidFill>
+                  <a:srgbClr val="0F1620"/>
+                </a:solidFill>
+                <a:latin typeface="Calibri"/>
+              </a:rPr>
+              <a:t>≈4 model calls per 20-question paper; a cached re-run costs nothing</a:t>
+            </a:r>
+          </a:p>
+        </p:txBody>
+      </p:sp>
+      <p:sp>
+        <p:nvSpPr>
+          <p:cNvPr id="71" name="TextBox 70"/>
+          <p:cNvSpPr txBox="1"/>
+          <p:nvPr/>
+        </p:nvSpPr>
+        <p:spPr>
+          <a:xfrm>
+            <a:off x="6172200" y="5413248"/>
+            <a:ext cx="914400" cy="566928"/>
+          </a:xfrm>
+          <a:prstGeom prst="rect">
+            <a:avLst/>
+          </a:prstGeom>
+          <a:noFill/>
+        </p:spPr>
+        <p:txBody>
+          <a:bodyPr wrap="square" lIns="0" rIns="0" tIns="0" bIns="0" anchor="ctr">
+            <a:spAutoFit/>
+          </a:bodyPr>
+          <a:lstStyle/>
+          <a:p>
+            <a:pPr algn="l"/>
+            <a:r>
+              <a:rPr sz="1000" b="1" i="0" spc="200">
+                <a:solidFill>
+                  <a:srgbClr val="0F4C81"/>
+                </a:solidFill>
+                <a:latin typeface="Calibri"/>
+              </a:rPr>
+              <a:t>CHANNELS</a:t>
+            </a:r>
+          </a:p>
+        </p:txBody>
+      </p:sp>
+      <p:sp>
+        <p:nvSpPr>
+          <p:cNvPr id="72" name="TextBox 71"/>
+          <p:cNvSpPr txBox="1"/>
+          <p:nvPr/>
+        </p:nvSpPr>
+        <p:spPr>
+          <a:xfrm>
+            <a:off x="7086600" y="5413248"/>
+            <a:ext cx="4297680" cy="566928"/>
+          </a:xfrm>
+          <a:prstGeom prst="rect">
+            <a:avLst/>
+          </a:prstGeom>
+          <a:noFill/>
+        </p:spPr>
+        <p:txBody>
+          <a:bodyPr wrap="square" lIns="0" rIns="0" tIns="0" bIns="0" anchor="ctr">
+            <a:spAutoFit/>
+          </a:bodyPr>
+          <a:lstStyle/>
+          <a:p>
+            <a:pPr algn="l"/>
+            <a:r>
+              <a:rPr sz="1100" b="0" i="0">
+                <a:solidFill>
+                  <a:srgbClr val="0F1620"/>
+                </a:solidFill>
+                <a:latin typeface="Calibri"/>
+              </a:rPr>
+              <a:t>Web app  ·  department licences  ·  card, JazzCash or Easypaisa</a:t>
+            </a:r>
+          </a:p>
+        </p:txBody>
+      </p:sp>
+    </p:spTree>
+  </p:cSld>
+  <p:clrMapOvr>
+    <a:masterClrMapping/>
+  </p:clrMapOvr>
+</p:sld>
+</file>
+
+<file path=ppt/slides/slide16.xml><?xml version="1.0" encoding="utf-8"?>
 <p:sld xmlns:a="http://schemas.openxmlformats.org/drawingml/2006/main" xmlns:r="http://schemas.openxmlformats.org/officeDocument/2006/relationships" xmlns:p="http://schemas.openxmlformats.org/presentationml/2006/main">
   <p:cSld name="Slide 14">
     <p:bg>

</xml_diff>